<commit_message>
Slides V1.3 github complete
</commit_message>
<xml_diff>
--- a/Git - GitHub training.pptx
+++ b/Git - GitHub training.pptx
@@ -11297,6 +11297,183 @@
           </a:prstGeom>
         </p:spPr>
       </p:pic>
+      <p:sp>
+        <p:nvSpPr>
+          <p:cNvPr id="7" name="TextBox 6">
+            <a:extLst>
+              <a:ext uri="{FF2B5EF4-FFF2-40B4-BE49-F238E27FC236}">
+                <a16:creationId xmlns:a16="http://schemas.microsoft.com/office/drawing/2014/main" id="{5F77A991-BF88-E87B-9209-31C2C7205446}"/>
+              </a:ext>
+            </a:extLst>
+          </p:cNvPr>
+          <p:cNvSpPr txBox="1"/>
+          <p:nvPr/>
+        </p:nvSpPr>
+        <p:spPr>
+          <a:xfrm>
+            <a:off x="8653670" y="5290468"/>
+            <a:ext cx="2407840" cy="369332"/>
+          </a:xfrm>
+          <a:prstGeom prst="rect">
+            <a:avLst/>
+          </a:prstGeom>
+          <a:noFill/>
+        </p:spPr>
+        <p:txBody>
+          <a:bodyPr wrap="square">
+            <a:spAutoFit/>
+          </a:bodyPr>
+          <a:lstStyle/>
+          <a:p>
+            <a:r>
+              <a:rPr lang="en-US" b="1" dirty="0"/>
+              <a:t>&gt; git clone &lt;repo </a:t>
+            </a:r>
+            <a:r>
+              <a:rPr lang="en-US" b="1" dirty="0" err="1"/>
+              <a:t>url</a:t>
+            </a:r>
+            <a:r>
+              <a:rPr lang="en-US" b="1" dirty="0"/>
+              <a:t>&gt;</a:t>
+            </a:r>
+          </a:p>
+        </p:txBody>
+      </p:sp>
+      <p:sp>
+        <p:nvSpPr>
+          <p:cNvPr id="8" name="Rectangle 7">
+            <a:extLst>
+              <a:ext uri="{FF2B5EF4-FFF2-40B4-BE49-F238E27FC236}">
+                <a16:creationId xmlns:a16="http://schemas.microsoft.com/office/drawing/2014/main" id="{1BEC20EC-4CF4-1036-F370-78EADF4DC5E0}"/>
+              </a:ext>
+            </a:extLst>
+          </p:cNvPr>
+          <p:cNvSpPr/>
+          <p:nvPr/>
+        </p:nvSpPr>
+        <p:spPr>
+          <a:xfrm>
+            <a:off x="5817029" y="2113722"/>
+            <a:ext cx="4088971" cy="175364"/>
+          </a:xfrm>
+          <a:prstGeom prst="rect">
+            <a:avLst/>
+          </a:prstGeom>
+          <a:noFill/>
+          <a:ln>
+            <a:solidFill>
+              <a:srgbClr val="FF0000"/>
+            </a:solidFill>
+          </a:ln>
+        </p:spPr>
+        <p:style>
+          <a:lnRef idx="2">
+            <a:schemeClr val="accent1">
+              <a:shade val="15000"/>
+            </a:schemeClr>
+          </a:lnRef>
+          <a:fillRef idx="1">
+            <a:schemeClr val="accent1"/>
+          </a:fillRef>
+          <a:effectRef idx="0">
+            <a:schemeClr val="accent1"/>
+          </a:effectRef>
+          <a:fontRef idx="minor">
+            <a:schemeClr val="lt1"/>
+          </a:fontRef>
+        </p:style>
+        <p:txBody>
+          <a:bodyPr rtlCol="0" anchor="ctr"/>
+          <a:lstStyle/>
+          <a:p>
+            <a:pPr algn="ctr"/>
+            <a:endParaRPr lang="en-US" dirty="0"/>
+          </a:p>
+        </p:txBody>
+      </p:sp>
+      <p:cxnSp>
+        <p:nvCxnSpPr>
+          <p:cNvPr id="9" name="Straight Arrow Connector 8">
+            <a:extLst>
+              <a:ext uri="{FF2B5EF4-FFF2-40B4-BE49-F238E27FC236}">
+                <a16:creationId xmlns:a16="http://schemas.microsoft.com/office/drawing/2014/main" id="{755C5EC9-483B-F8E9-D23D-AE1B8DE36468}"/>
+              </a:ext>
+            </a:extLst>
+          </p:cNvPr>
+          <p:cNvCxnSpPr>
+            <a:cxnSpLocks/>
+            <a:stCxn id="14" idx="3"/>
+            <a:endCxn id="8" idx="1"/>
+          </p:cNvCxnSpPr>
+          <p:nvPr/>
+        </p:nvCxnSpPr>
+        <p:spPr>
+          <a:xfrm flipV="1">
+            <a:off x="3964256" y="2201404"/>
+            <a:ext cx="1852773" cy="327817"/>
+          </a:xfrm>
+          <a:prstGeom prst="straightConnector1">
+            <a:avLst/>
+          </a:prstGeom>
+          <a:ln w="57150">
+            <a:solidFill>
+              <a:srgbClr val="FF0000"/>
+            </a:solidFill>
+            <a:tailEnd type="triangle"/>
+          </a:ln>
+        </p:spPr>
+        <p:style>
+          <a:lnRef idx="2">
+            <a:schemeClr val="accent1"/>
+          </a:lnRef>
+          <a:fillRef idx="0">
+            <a:schemeClr val="accent1"/>
+          </a:fillRef>
+          <a:effectRef idx="1">
+            <a:schemeClr val="accent1"/>
+          </a:effectRef>
+          <a:fontRef idx="minor">
+            <a:schemeClr val="tx1"/>
+          </a:fontRef>
+        </p:style>
+      </p:cxnSp>
+      <p:sp>
+        <p:nvSpPr>
+          <p:cNvPr id="14" name="TextBox 13">
+            <a:extLst>
+              <a:ext uri="{FF2B5EF4-FFF2-40B4-BE49-F238E27FC236}">
+                <a16:creationId xmlns:a16="http://schemas.microsoft.com/office/drawing/2014/main" id="{B064080B-0B2C-1745-DC29-EA07E6677B56}"/>
+              </a:ext>
+            </a:extLst>
+          </p:cNvPr>
+          <p:cNvSpPr txBox="1"/>
+          <p:nvPr/>
+        </p:nvSpPr>
+        <p:spPr>
+          <a:xfrm>
+            <a:off x="838200" y="2113722"/>
+            <a:ext cx="3126056" cy="830997"/>
+          </a:xfrm>
+          <a:prstGeom prst="rect">
+            <a:avLst/>
+          </a:prstGeom>
+          <a:noFill/>
+        </p:spPr>
+        <p:txBody>
+          <a:bodyPr wrap="square" rtlCol="0">
+            <a:spAutoFit/>
+          </a:bodyPr>
+          <a:lstStyle/>
+          <a:p>
+            <a:pPr algn="ctr"/>
+            <a:r>
+              <a:rPr lang="en-US" sz="1600" dirty="0"/>
+              <a:t>Downloads remote repository in current folder with repo name as folder name</a:t>
+            </a:r>
+          </a:p>
+        </p:txBody>
+      </p:sp>
     </p:spTree>
     <p:extLst>
       <p:ext uri="{BB962C8B-B14F-4D97-AF65-F5344CB8AC3E}">
@@ -11382,7 +11559,7 @@
         </p:blipFill>
         <p:spPr>
           <a:xfrm>
-            <a:off x="4708099" y="487012"/>
+            <a:off x="4661716" y="122577"/>
             <a:ext cx="7205811" cy="6005863"/>
           </a:xfrm>
           <a:prstGeom prst="rect">
@@ -11390,6 +11567,443 @@
           </a:prstGeom>
         </p:spPr>
       </p:pic>
+      <p:cxnSp>
+        <p:nvCxnSpPr>
+          <p:cNvPr id="6" name="Straight Arrow Connector 5">
+            <a:extLst>
+              <a:ext uri="{FF2B5EF4-FFF2-40B4-BE49-F238E27FC236}">
+                <a16:creationId xmlns:a16="http://schemas.microsoft.com/office/drawing/2014/main" id="{0F259876-99F2-2EA7-E659-F841C9300ADA}"/>
+              </a:ext>
+            </a:extLst>
+          </p:cNvPr>
+          <p:cNvCxnSpPr>
+            <a:cxnSpLocks/>
+            <a:stCxn id="7" idx="3"/>
+            <a:endCxn id="9" idx="1"/>
+          </p:cNvCxnSpPr>
+          <p:nvPr/>
+        </p:nvCxnSpPr>
+        <p:spPr>
+          <a:xfrm>
+            <a:off x="3964256" y="4189632"/>
+            <a:ext cx="2581643" cy="415498"/>
+          </a:xfrm>
+          <a:prstGeom prst="straightConnector1">
+            <a:avLst/>
+          </a:prstGeom>
+          <a:ln w="57150">
+            <a:solidFill>
+              <a:srgbClr val="FF0000"/>
+            </a:solidFill>
+            <a:tailEnd type="triangle"/>
+          </a:ln>
+        </p:spPr>
+        <p:style>
+          <a:lnRef idx="2">
+            <a:schemeClr val="accent1"/>
+          </a:lnRef>
+          <a:fillRef idx="0">
+            <a:schemeClr val="accent1"/>
+          </a:fillRef>
+          <a:effectRef idx="1">
+            <a:schemeClr val="accent1"/>
+          </a:effectRef>
+          <a:fontRef idx="minor">
+            <a:schemeClr val="tx1"/>
+          </a:fontRef>
+        </p:style>
+      </p:cxnSp>
+      <p:sp>
+        <p:nvSpPr>
+          <p:cNvPr id="7" name="TextBox 6">
+            <a:extLst>
+              <a:ext uri="{FF2B5EF4-FFF2-40B4-BE49-F238E27FC236}">
+                <a16:creationId xmlns:a16="http://schemas.microsoft.com/office/drawing/2014/main" id="{DE9B05F0-3C8D-9F66-85E6-1521E8DF33B5}"/>
+              </a:ext>
+            </a:extLst>
+          </p:cNvPr>
+          <p:cNvSpPr txBox="1"/>
+          <p:nvPr/>
+        </p:nvSpPr>
+        <p:spPr>
+          <a:xfrm>
+            <a:off x="838200" y="3774133"/>
+            <a:ext cx="3126056" cy="830997"/>
+          </a:xfrm>
+          <a:prstGeom prst="rect">
+            <a:avLst/>
+          </a:prstGeom>
+          <a:noFill/>
+        </p:spPr>
+        <p:txBody>
+          <a:bodyPr wrap="square" rtlCol="0">
+            <a:spAutoFit/>
+          </a:bodyPr>
+          <a:lstStyle/>
+          <a:p>
+            <a:pPr algn="ctr"/>
+            <a:r>
+              <a:rPr lang="en-US" sz="1600" dirty="0"/>
+              <a:t>Pushes commits from local branch that are ahead of remote branch (origin)</a:t>
+            </a:r>
+          </a:p>
+        </p:txBody>
+      </p:sp>
+      <p:sp>
+        <p:nvSpPr>
+          <p:cNvPr id="9" name="Rectangle 8">
+            <a:extLst>
+              <a:ext uri="{FF2B5EF4-FFF2-40B4-BE49-F238E27FC236}">
+                <a16:creationId xmlns:a16="http://schemas.microsoft.com/office/drawing/2014/main" id="{E1EE9C9F-8306-70D7-54C6-21F34ACBE174}"/>
+              </a:ext>
+            </a:extLst>
+          </p:cNvPr>
+          <p:cNvSpPr/>
+          <p:nvPr/>
+        </p:nvSpPr>
+        <p:spPr>
+          <a:xfrm>
+            <a:off x="6545899" y="4518991"/>
+            <a:ext cx="2286676" cy="172278"/>
+          </a:xfrm>
+          <a:prstGeom prst="rect">
+            <a:avLst/>
+          </a:prstGeom>
+          <a:noFill/>
+          <a:ln>
+            <a:solidFill>
+              <a:srgbClr val="FF0000"/>
+            </a:solidFill>
+          </a:ln>
+        </p:spPr>
+        <p:style>
+          <a:lnRef idx="2">
+            <a:schemeClr val="accent1">
+              <a:shade val="15000"/>
+            </a:schemeClr>
+          </a:lnRef>
+          <a:fillRef idx="1">
+            <a:schemeClr val="accent1"/>
+          </a:fillRef>
+          <a:effectRef idx="0">
+            <a:schemeClr val="accent1"/>
+          </a:effectRef>
+          <a:fontRef idx="minor">
+            <a:schemeClr val="lt1"/>
+          </a:fontRef>
+        </p:style>
+        <p:txBody>
+          <a:bodyPr rtlCol="0" anchor="ctr"/>
+          <a:lstStyle/>
+          <a:p>
+            <a:pPr algn="ctr"/>
+            <a:endParaRPr lang="en-US" dirty="0"/>
+          </a:p>
+        </p:txBody>
+      </p:sp>
+      <p:sp>
+        <p:nvSpPr>
+          <p:cNvPr id="12" name="TextBox 11">
+            <a:extLst>
+              <a:ext uri="{FF2B5EF4-FFF2-40B4-BE49-F238E27FC236}">
+                <a16:creationId xmlns:a16="http://schemas.microsoft.com/office/drawing/2014/main" id="{536165CF-87C1-8C39-580A-3D22E0F187F1}"/>
+              </a:ext>
+            </a:extLst>
+          </p:cNvPr>
+          <p:cNvSpPr txBox="1"/>
+          <p:nvPr/>
+        </p:nvSpPr>
+        <p:spPr>
+          <a:xfrm>
+            <a:off x="9044609" y="6186322"/>
+            <a:ext cx="2985052" cy="369332"/>
+          </a:xfrm>
+          <a:prstGeom prst="rect">
+            <a:avLst/>
+          </a:prstGeom>
+          <a:noFill/>
+        </p:spPr>
+        <p:txBody>
+          <a:bodyPr wrap="square">
+            <a:spAutoFit/>
+          </a:bodyPr>
+          <a:lstStyle/>
+          <a:p>
+            <a:r>
+              <a:rPr lang="en-US" b="1" dirty="0"/>
+              <a:t>&gt; git push origin &lt;branch&gt;</a:t>
+            </a:r>
+          </a:p>
+        </p:txBody>
+      </p:sp>
+      <p:sp>
+        <p:nvSpPr>
+          <p:cNvPr id="13" name="Rectangle 12">
+            <a:extLst>
+              <a:ext uri="{FF2B5EF4-FFF2-40B4-BE49-F238E27FC236}">
+                <a16:creationId xmlns:a16="http://schemas.microsoft.com/office/drawing/2014/main" id="{7E6BA0BE-6605-B966-CB6D-2487A0637A5A}"/>
+              </a:ext>
+            </a:extLst>
+          </p:cNvPr>
+          <p:cNvSpPr/>
+          <p:nvPr/>
+        </p:nvSpPr>
+        <p:spPr>
+          <a:xfrm>
+            <a:off x="8250459" y="1933236"/>
+            <a:ext cx="1761558" cy="259089"/>
+          </a:xfrm>
+          <a:prstGeom prst="rect">
+            <a:avLst/>
+          </a:prstGeom>
+          <a:noFill/>
+          <a:ln>
+            <a:solidFill>
+              <a:srgbClr val="FF0000"/>
+            </a:solidFill>
+          </a:ln>
+        </p:spPr>
+        <p:style>
+          <a:lnRef idx="2">
+            <a:schemeClr val="accent1">
+              <a:shade val="15000"/>
+            </a:schemeClr>
+          </a:lnRef>
+          <a:fillRef idx="1">
+            <a:schemeClr val="accent1"/>
+          </a:fillRef>
+          <a:effectRef idx="0">
+            <a:schemeClr val="accent1"/>
+          </a:effectRef>
+          <a:fontRef idx="minor">
+            <a:schemeClr val="lt1"/>
+          </a:fontRef>
+        </p:style>
+        <p:txBody>
+          <a:bodyPr rtlCol="0" anchor="ctr"/>
+          <a:lstStyle/>
+          <a:p>
+            <a:pPr algn="ctr"/>
+            <a:endParaRPr lang="en-US" dirty="0"/>
+          </a:p>
+        </p:txBody>
+      </p:sp>
+      <p:sp>
+        <p:nvSpPr>
+          <p:cNvPr id="14" name="Rectangle 13">
+            <a:extLst>
+              <a:ext uri="{FF2B5EF4-FFF2-40B4-BE49-F238E27FC236}">
+                <a16:creationId xmlns:a16="http://schemas.microsoft.com/office/drawing/2014/main" id="{4BB3A11B-2FA4-6D1A-5DD6-11CB482E1EF8}"/>
+              </a:ext>
+            </a:extLst>
+          </p:cNvPr>
+          <p:cNvSpPr/>
+          <p:nvPr/>
+        </p:nvSpPr>
+        <p:spPr>
+          <a:xfrm>
+            <a:off x="10012017" y="5319167"/>
+            <a:ext cx="1761558" cy="259089"/>
+          </a:xfrm>
+          <a:prstGeom prst="rect">
+            <a:avLst/>
+          </a:prstGeom>
+          <a:noFill/>
+          <a:ln>
+            <a:solidFill>
+              <a:srgbClr val="FF0000"/>
+            </a:solidFill>
+          </a:ln>
+        </p:spPr>
+        <p:style>
+          <a:lnRef idx="2">
+            <a:schemeClr val="accent1">
+              <a:shade val="15000"/>
+            </a:schemeClr>
+          </a:lnRef>
+          <a:fillRef idx="1">
+            <a:schemeClr val="accent1"/>
+          </a:fillRef>
+          <a:effectRef idx="0">
+            <a:schemeClr val="accent1"/>
+          </a:effectRef>
+          <a:fontRef idx="minor">
+            <a:schemeClr val="lt1"/>
+          </a:fontRef>
+        </p:style>
+        <p:txBody>
+          <a:bodyPr rtlCol="0" anchor="ctr"/>
+          <a:lstStyle/>
+          <a:p>
+            <a:pPr algn="ctr"/>
+            <a:endParaRPr lang="en-US" dirty="0"/>
+          </a:p>
+        </p:txBody>
+      </p:sp>
+      <p:cxnSp>
+        <p:nvCxnSpPr>
+          <p:cNvPr id="15" name="Straight Arrow Connector 14">
+            <a:extLst>
+              <a:ext uri="{FF2B5EF4-FFF2-40B4-BE49-F238E27FC236}">
+                <a16:creationId xmlns:a16="http://schemas.microsoft.com/office/drawing/2014/main" id="{C2BE4478-0B02-1C22-A2C5-BE6C524F0DA6}"/>
+              </a:ext>
+            </a:extLst>
+          </p:cNvPr>
+          <p:cNvCxnSpPr>
+            <a:cxnSpLocks/>
+            <a:stCxn id="18" idx="3"/>
+            <a:endCxn id="13" idx="1"/>
+          </p:cNvCxnSpPr>
+          <p:nvPr/>
+        </p:nvCxnSpPr>
+        <p:spPr>
+          <a:xfrm flipV="1">
+            <a:off x="3897996" y="2062781"/>
+            <a:ext cx="4352463" cy="298821"/>
+          </a:xfrm>
+          <a:prstGeom prst="straightConnector1">
+            <a:avLst/>
+          </a:prstGeom>
+          <a:ln w="57150">
+            <a:solidFill>
+              <a:srgbClr val="FF0000"/>
+            </a:solidFill>
+            <a:tailEnd type="triangle"/>
+          </a:ln>
+        </p:spPr>
+        <p:style>
+          <a:lnRef idx="2">
+            <a:schemeClr val="accent1"/>
+          </a:lnRef>
+          <a:fillRef idx="0">
+            <a:schemeClr val="accent1"/>
+          </a:fillRef>
+          <a:effectRef idx="1">
+            <a:schemeClr val="accent1"/>
+          </a:effectRef>
+          <a:fontRef idx="minor">
+            <a:schemeClr val="tx1"/>
+          </a:fontRef>
+        </p:style>
+      </p:cxnSp>
+      <p:sp>
+        <p:nvSpPr>
+          <p:cNvPr id="18" name="TextBox 17">
+            <a:extLst>
+              <a:ext uri="{FF2B5EF4-FFF2-40B4-BE49-F238E27FC236}">
+                <a16:creationId xmlns:a16="http://schemas.microsoft.com/office/drawing/2014/main" id="{E02125CA-17BB-D3D3-0A62-C004A9A3B31F}"/>
+              </a:ext>
+            </a:extLst>
+          </p:cNvPr>
+          <p:cNvSpPr txBox="1"/>
+          <p:nvPr/>
+        </p:nvSpPr>
+        <p:spPr>
+          <a:xfrm>
+            <a:off x="771940" y="2192325"/>
+            <a:ext cx="3126056" cy="338554"/>
+          </a:xfrm>
+          <a:prstGeom prst="rect">
+            <a:avLst/>
+          </a:prstGeom>
+          <a:noFill/>
+        </p:spPr>
+        <p:txBody>
+          <a:bodyPr wrap="square" rtlCol="0">
+            <a:spAutoFit/>
+          </a:bodyPr>
+          <a:lstStyle/>
+          <a:p>
+            <a:pPr algn="ctr"/>
+            <a:r>
+              <a:rPr lang="en-US" sz="1600" dirty="0"/>
+              <a:t>Last tracked remote change</a:t>
+            </a:r>
+          </a:p>
+        </p:txBody>
+      </p:sp>
+      <p:sp>
+        <p:nvSpPr>
+          <p:cNvPr id="20" name="TextBox 19">
+            <a:extLst>
+              <a:ext uri="{FF2B5EF4-FFF2-40B4-BE49-F238E27FC236}">
+                <a16:creationId xmlns:a16="http://schemas.microsoft.com/office/drawing/2014/main" id="{FD69771E-EDB0-A7EB-9D2D-84D85A1720AD}"/>
+              </a:ext>
+            </a:extLst>
+          </p:cNvPr>
+          <p:cNvSpPr txBox="1"/>
+          <p:nvPr/>
+        </p:nvSpPr>
+        <p:spPr>
+          <a:xfrm>
+            <a:off x="4031975" y="6263883"/>
+            <a:ext cx="3126056" cy="338554"/>
+          </a:xfrm>
+          <a:prstGeom prst="rect">
+            <a:avLst/>
+          </a:prstGeom>
+          <a:noFill/>
+        </p:spPr>
+        <p:txBody>
+          <a:bodyPr wrap="square" rtlCol="0">
+            <a:spAutoFit/>
+          </a:bodyPr>
+          <a:lstStyle/>
+          <a:p>
+            <a:pPr algn="ctr"/>
+            <a:r>
+              <a:rPr lang="en-US" sz="1600" dirty="0"/>
+              <a:t>New tracked remote change</a:t>
+            </a:r>
+          </a:p>
+        </p:txBody>
+      </p:sp>
+      <p:cxnSp>
+        <p:nvCxnSpPr>
+          <p:cNvPr id="21" name="Straight Arrow Connector 20">
+            <a:extLst>
+              <a:ext uri="{FF2B5EF4-FFF2-40B4-BE49-F238E27FC236}">
+                <a16:creationId xmlns:a16="http://schemas.microsoft.com/office/drawing/2014/main" id="{2DD889E5-87E4-1CD4-E863-25AFC9391B87}"/>
+              </a:ext>
+            </a:extLst>
+          </p:cNvPr>
+          <p:cNvCxnSpPr>
+            <a:cxnSpLocks/>
+            <a:stCxn id="20" idx="3"/>
+            <a:endCxn id="14" idx="1"/>
+          </p:cNvCxnSpPr>
+          <p:nvPr/>
+        </p:nvCxnSpPr>
+        <p:spPr>
+          <a:xfrm flipV="1">
+            <a:off x="7158031" y="5448712"/>
+            <a:ext cx="2853986" cy="984448"/>
+          </a:xfrm>
+          <a:prstGeom prst="straightConnector1">
+            <a:avLst/>
+          </a:prstGeom>
+          <a:ln w="57150">
+            <a:solidFill>
+              <a:srgbClr val="FF0000"/>
+            </a:solidFill>
+            <a:tailEnd type="triangle"/>
+          </a:ln>
+        </p:spPr>
+        <p:style>
+          <a:lnRef idx="2">
+            <a:schemeClr val="accent1"/>
+          </a:lnRef>
+          <a:fillRef idx="0">
+            <a:schemeClr val="accent1"/>
+          </a:fillRef>
+          <a:effectRef idx="1">
+            <a:schemeClr val="accent1"/>
+          </a:effectRef>
+          <a:fontRef idx="minor">
+            <a:schemeClr val="tx1"/>
+          </a:fontRef>
+        </p:style>
+      </p:cxnSp>
     </p:spTree>
     <p:extLst>
       <p:ext uri="{BB962C8B-B14F-4D97-AF65-F5344CB8AC3E}">
@@ -11483,6 +12097,345 @@
           </a:prstGeom>
         </p:spPr>
       </p:pic>
+      <p:sp>
+        <p:nvSpPr>
+          <p:cNvPr id="7" name="Rectangle 6">
+            <a:extLst>
+              <a:ext uri="{FF2B5EF4-FFF2-40B4-BE49-F238E27FC236}">
+                <a16:creationId xmlns:a16="http://schemas.microsoft.com/office/drawing/2014/main" id="{6D8EEEA4-B684-0653-5992-1AB948A64381}"/>
+              </a:ext>
+            </a:extLst>
+          </p:cNvPr>
+          <p:cNvSpPr/>
+          <p:nvPr/>
+        </p:nvSpPr>
+        <p:spPr>
+          <a:xfrm>
+            <a:off x="6566439" y="4396740"/>
+            <a:ext cx="847821" cy="203505"/>
+          </a:xfrm>
+          <a:prstGeom prst="rect">
+            <a:avLst/>
+          </a:prstGeom>
+          <a:noFill/>
+          <a:ln>
+            <a:solidFill>
+              <a:srgbClr val="FF0000"/>
+            </a:solidFill>
+          </a:ln>
+        </p:spPr>
+        <p:style>
+          <a:lnRef idx="2">
+            <a:schemeClr val="accent1">
+              <a:shade val="15000"/>
+            </a:schemeClr>
+          </a:lnRef>
+          <a:fillRef idx="1">
+            <a:schemeClr val="accent1"/>
+          </a:fillRef>
+          <a:effectRef idx="0">
+            <a:schemeClr val="accent1"/>
+          </a:effectRef>
+          <a:fontRef idx="minor">
+            <a:schemeClr val="lt1"/>
+          </a:fontRef>
+        </p:style>
+        <p:txBody>
+          <a:bodyPr rtlCol="0" anchor="ctr"/>
+          <a:lstStyle/>
+          <a:p>
+            <a:pPr algn="ctr"/>
+            <a:endParaRPr lang="en-US" dirty="0"/>
+          </a:p>
+        </p:txBody>
+      </p:sp>
+      <p:cxnSp>
+        <p:nvCxnSpPr>
+          <p:cNvPr id="8" name="Straight Arrow Connector 7">
+            <a:extLst>
+              <a:ext uri="{FF2B5EF4-FFF2-40B4-BE49-F238E27FC236}">
+                <a16:creationId xmlns:a16="http://schemas.microsoft.com/office/drawing/2014/main" id="{EBC5524A-4F75-1AE7-EC4B-611C5E27442A}"/>
+              </a:ext>
+            </a:extLst>
+          </p:cNvPr>
+          <p:cNvCxnSpPr>
+            <a:cxnSpLocks/>
+            <a:stCxn id="9" idx="3"/>
+            <a:endCxn id="7" idx="1"/>
+          </p:cNvCxnSpPr>
+          <p:nvPr/>
+        </p:nvCxnSpPr>
+        <p:spPr>
+          <a:xfrm>
+            <a:off x="3776076" y="4390904"/>
+            <a:ext cx="2790363" cy="107589"/>
+          </a:xfrm>
+          <a:prstGeom prst="straightConnector1">
+            <a:avLst/>
+          </a:prstGeom>
+          <a:ln w="57150">
+            <a:solidFill>
+              <a:srgbClr val="FF0000"/>
+            </a:solidFill>
+            <a:tailEnd type="triangle"/>
+          </a:ln>
+        </p:spPr>
+        <p:style>
+          <a:lnRef idx="2">
+            <a:schemeClr val="accent1"/>
+          </a:lnRef>
+          <a:fillRef idx="0">
+            <a:schemeClr val="accent1"/>
+          </a:fillRef>
+          <a:effectRef idx="1">
+            <a:schemeClr val="accent1"/>
+          </a:effectRef>
+          <a:fontRef idx="minor">
+            <a:schemeClr val="tx1"/>
+          </a:fontRef>
+        </p:style>
+      </p:cxnSp>
+      <p:sp>
+        <p:nvSpPr>
+          <p:cNvPr id="9" name="TextBox 8">
+            <a:extLst>
+              <a:ext uri="{FF2B5EF4-FFF2-40B4-BE49-F238E27FC236}">
+                <a16:creationId xmlns:a16="http://schemas.microsoft.com/office/drawing/2014/main" id="{E65B9524-6B0B-3817-7C0F-616CFD2BC81D}"/>
+              </a:ext>
+            </a:extLst>
+          </p:cNvPr>
+          <p:cNvSpPr txBox="1"/>
+          <p:nvPr/>
+        </p:nvSpPr>
+        <p:spPr>
+          <a:xfrm>
+            <a:off x="650020" y="3975405"/>
+            <a:ext cx="3126056" cy="830997"/>
+          </a:xfrm>
+          <a:prstGeom prst="rect">
+            <a:avLst/>
+          </a:prstGeom>
+          <a:noFill/>
+        </p:spPr>
+        <p:txBody>
+          <a:bodyPr wrap="square" rtlCol="0">
+            <a:spAutoFit/>
+          </a:bodyPr>
+          <a:lstStyle/>
+          <a:p>
+            <a:pPr algn="ctr"/>
+            <a:r>
+              <a:rPr lang="en-US" sz="1600" dirty="0"/>
+              <a:t>Updates git tree without modifying work directory nor HEAD/local branch</a:t>
+            </a:r>
+          </a:p>
+        </p:txBody>
+      </p:sp>
+      <p:sp>
+        <p:nvSpPr>
+          <p:cNvPr id="15" name="TextBox 14">
+            <a:extLst>
+              <a:ext uri="{FF2B5EF4-FFF2-40B4-BE49-F238E27FC236}">
+                <a16:creationId xmlns:a16="http://schemas.microsoft.com/office/drawing/2014/main" id="{2678344C-3DBA-9981-4484-650451345C61}"/>
+              </a:ext>
+            </a:extLst>
+          </p:cNvPr>
+          <p:cNvSpPr txBox="1"/>
+          <p:nvPr/>
+        </p:nvSpPr>
+        <p:spPr>
+          <a:xfrm>
+            <a:off x="650020" y="1948485"/>
+            <a:ext cx="3126056" cy="338554"/>
+          </a:xfrm>
+          <a:prstGeom prst="rect">
+            <a:avLst/>
+          </a:prstGeom>
+          <a:noFill/>
+        </p:spPr>
+        <p:txBody>
+          <a:bodyPr wrap="square" rtlCol="0">
+            <a:spAutoFit/>
+          </a:bodyPr>
+          <a:lstStyle/>
+          <a:p>
+            <a:pPr algn="ctr"/>
+            <a:r>
+              <a:rPr lang="en-US" sz="1600" dirty="0"/>
+              <a:t>Last known state of the repo</a:t>
+            </a:r>
+          </a:p>
+        </p:txBody>
+      </p:sp>
+      <p:sp>
+        <p:nvSpPr>
+          <p:cNvPr id="16" name="TextBox 15">
+            <a:extLst>
+              <a:ext uri="{FF2B5EF4-FFF2-40B4-BE49-F238E27FC236}">
+                <a16:creationId xmlns:a16="http://schemas.microsoft.com/office/drawing/2014/main" id="{97955298-ED37-3088-1134-2F4B0A501695}"/>
+              </a:ext>
+            </a:extLst>
+          </p:cNvPr>
+          <p:cNvSpPr txBox="1"/>
+          <p:nvPr/>
+        </p:nvSpPr>
+        <p:spPr>
+          <a:xfrm>
+            <a:off x="650020" y="5221901"/>
+            <a:ext cx="3126056" cy="830997"/>
+          </a:xfrm>
+          <a:prstGeom prst="rect">
+            <a:avLst/>
+          </a:prstGeom>
+          <a:noFill/>
+        </p:spPr>
+        <p:txBody>
+          <a:bodyPr wrap="square" rtlCol="0">
+            <a:spAutoFit/>
+          </a:bodyPr>
+          <a:lstStyle/>
+          <a:p>
+            <a:pPr algn="ctr"/>
+            <a:r>
+              <a:rPr lang="en-US" sz="1600" dirty="0"/>
+              <a:t>Commits ahead that remote branch is with respect to local last known state</a:t>
+            </a:r>
+          </a:p>
+        </p:txBody>
+      </p:sp>
+      <p:sp>
+        <p:nvSpPr>
+          <p:cNvPr id="17" name="Rectangle 16">
+            <a:extLst>
+              <a:ext uri="{FF2B5EF4-FFF2-40B4-BE49-F238E27FC236}">
+                <a16:creationId xmlns:a16="http://schemas.microsoft.com/office/drawing/2014/main" id="{5B023DDA-10F7-48ED-ECE4-4911A3E33E71}"/>
+              </a:ext>
+            </a:extLst>
+          </p:cNvPr>
+          <p:cNvSpPr/>
+          <p:nvPr/>
+        </p:nvSpPr>
+        <p:spPr>
+          <a:xfrm>
+            <a:off x="4463319" y="4710487"/>
+            <a:ext cx="4692873" cy="203505"/>
+          </a:xfrm>
+          <a:prstGeom prst="rect">
+            <a:avLst/>
+          </a:prstGeom>
+          <a:noFill/>
+          <a:ln>
+            <a:solidFill>
+              <a:srgbClr val="FF0000"/>
+            </a:solidFill>
+          </a:ln>
+        </p:spPr>
+        <p:style>
+          <a:lnRef idx="2">
+            <a:schemeClr val="accent1">
+              <a:shade val="15000"/>
+            </a:schemeClr>
+          </a:lnRef>
+          <a:fillRef idx="1">
+            <a:schemeClr val="accent1"/>
+          </a:fillRef>
+          <a:effectRef idx="0">
+            <a:schemeClr val="accent1"/>
+          </a:effectRef>
+          <a:fontRef idx="minor">
+            <a:schemeClr val="lt1"/>
+          </a:fontRef>
+        </p:style>
+        <p:txBody>
+          <a:bodyPr rtlCol="0" anchor="ctr"/>
+          <a:lstStyle/>
+          <a:p>
+            <a:pPr algn="ctr"/>
+            <a:endParaRPr lang="en-US" dirty="0"/>
+          </a:p>
+        </p:txBody>
+      </p:sp>
+      <p:cxnSp>
+        <p:nvCxnSpPr>
+          <p:cNvPr id="18" name="Straight Arrow Connector 17">
+            <a:extLst>
+              <a:ext uri="{FF2B5EF4-FFF2-40B4-BE49-F238E27FC236}">
+                <a16:creationId xmlns:a16="http://schemas.microsoft.com/office/drawing/2014/main" id="{4BB7A938-5DEB-7777-38AF-270AF19C0F9E}"/>
+              </a:ext>
+            </a:extLst>
+          </p:cNvPr>
+          <p:cNvCxnSpPr>
+            <a:cxnSpLocks/>
+            <a:stCxn id="16" idx="3"/>
+            <a:endCxn id="17" idx="1"/>
+          </p:cNvCxnSpPr>
+          <p:nvPr/>
+        </p:nvCxnSpPr>
+        <p:spPr>
+          <a:xfrm flipV="1">
+            <a:off x="3776076" y="4812240"/>
+            <a:ext cx="687243" cy="825160"/>
+          </a:xfrm>
+          <a:prstGeom prst="straightConnector1">
+            <a:avLst/>
+          </a:prstGeom>
+          <a:ln w="57150">
+            <a:solidFill>
+              <a:srgbClr val="FF0000"/>
+            </a:solidFill>
+            <a:tailEnd type="triangle"/>
+          </a:ln>
+        </p:spPr>
+        <p:style>
+          <a:lnRef idx="2">
+            <a:schemeClr val="accent1"/>
+          </a:lnRef>
+          <a:fillRef idx="0">
+            <a:schemeClr val="accent1"/>
+          </a:fillRef>
+          <a:effectRef idx="1">
+            <a:schemeClr val="accent1"/>
+          </a:effectRef>
+          <a:fontRef idx="minor">
+            <a:schemeClr val="tx1"/>
+          </a:fontRef>
+        </p:style>
+      </p:cxnSp>
+      <p:sp>
+        <p:nvSpPr>
+          <p:cNvPr id="21" name="TextBox 20">
+            <a:extLst>
+              <a:ext uri="{FF2B5EF4-FFF2-40B4-BE49-F238E27FC236}">
+                <a16:creationId xmlns:a16="http://schemas.microsoft.com/office/drawing/2014/main" id="{C5A682B6-D982-2278-B609-B52D1346BC40}"/>
+              </a:ext>
+            </a:extLst>
+          </p:cNvPr>
+          <p:cNvSpPr txBox="1"/>
+          <p:nvPr/>
+        </p:nvSpPr>
+        <p:spPr>
+          <a:xfrm>
+            <a:off x="10771632" y="6108430"/>
+            <a:ext cx="2985052" cy="369332"/>
+          </a:xfrm>
+          <a:prstGeom prst="rect">
+            <a:avLst/>
+          </a:prstGeom>
+          <a:noFill/>
+        </p:spPr>
+        <p:txBody>
+          <a:bodyPr wrap="square">
+            <a:spAutoFit/>
+          </a:bodyPr>
+          <a:lstStyle/>
+          <a:p>
+            <a:r>
+              <a:rPr lang="en-US" b="1" dirty="0"/>
+              <a:t>&gt; git fetch</a:t>
+            </a:r>
+          </a:p>
+        </p:txBody>
+      </p:sp>
     </p:spTree>
     <p:extLst>
       <p:ext uri="{BB962C8B-B14F-4D97-AF65-F5344CB8AC3E}">
@@ -11568,14 +12521,317 @@
         </p:blipFill>
         <p:spPr>
           <a:xfrm>
-            <a:off x="4249611" y="120802"/>
-            <a:ext cx="7576629" cy="6616396"/>
+            <a:off x="4866831" y="202810"/>
+            <a:ext cx="7081329" cy="6183868"/>
           </a:xfrm>
           <a:prstGeom prst="rect">
             <a:avLst/>
           </a:prstGeom>
         </p:spPr>
       </p:pic>
+      <p:sp>
+        <p:nvSpPr>
+          <p:cNvPr id="6" name="Rectangle 5">
+            <a:extLst>
+              <a:ext uri="{FF2B5EF4-FFF2-40B4-BE49-F238E27FC236}">
+                <a16:creationId xmlns:a16="http://schemas.microsoft.com/office/drawing/2014/main" id="{603F8F38-ED72-D87C-C343-0EC29ADDC6AD}"/>
+              </a:ext>
+            </a:extLst>
+          </p:cNvPr>
+          <p:cNvSpPr/>
+          <p:nvPr/>
+        </p:nvSpPr>
+        <p:spPr>
+          <a:xfrm>
+            <a:off x="7000780" y="2917586"/>
+            <a:ext cx="720108" cy="206614"/>
+          </a:xfrm>
+          <a:prstGeom prst="rect">
+            <a:avLst/>
+          </a:prstGeom>
+          <a:noFill/>
+          <a:ln>
+            <a:solidFill>
+              <a:srgbClr val="FF0000"/>
+            </a:solidFill>
+          </a:ln>
+        </p:spPr>
+        <p:style>
+          <a:lnRef idx="2">
+            <a:schemeClr val="accent1">
+              <a:shade val="15000"/>
+            </a:schemeClr>
+          </a:lnRef>
+          <a:fillRef idx="1">
+            <a:schemeClr val="accent1"/>
+          </a:fillRef>
+          <a:effectRef idx="0">
+            <a:schemeClr val="accent1"/>
+          </a:effectRef>
+          <a:fontRef idx="minor">
+            <a:schemeClr val="lt1"/>
+          </a:fontRef>
+        </p:style>
+        <p:txBody>
+          <a:bodyPr rtlCol="0" anchor="ctr"/>
+          <a:lstStyle/>
+          <a:p>
+            <a:pPr algn="ctr"/>
+            <a:endParaRPr lang="en-US" dirty="0"/>
+          </a:p>
+        </p:txBody>
+      </p:sp>
+      <p:cxnSp>
+        <p:nvCxnSpPr>
+          <p:cNvPr id="7" name="Straight Arrow Connector 6">
+            <a:extLst>
+              <a:ext uri="{FF2B5EF4-FFF2-40B4-BE49-F238E27FC236}">
+                <a16:creationId xmlns:a16="http://schemas.microsoft.com/office/drawing/2014/main" id="{85EB77A7-2FB5-83F4-9A06-73F8DCA02700}"/>
+              </a:ext>
+            </a:extLst>
+          </p:cNvPr>
+          <p:cNvCxnSpPr>
+            <a:cxnSpLocks/>
+            <a:stCxn id="8" idx="3"/>
+            <a:endCxn id="6" idx="1"/>
+          </p:cNvCxnSpPr>
+          <p:nvPr/>
+        </p:nvCxnSpPr>
+        <p:spPr>
+          <a:xfrm>
+            <a:off x="3692256" y="3013502"/>
+            <a:ext cx="3308524" cy="7391"/>
+          </a:xfrm>
+          <a:prstGeom prst="straightConnector1">
+            <a:avLst/>
+          </a:prstGeom>
+          <a:ln w="57150">
+            <a:solidFill>
+              <a:srgbClr val="FF0000"/>
+            </a:solidFill>
+            <a:tailEnd type="triangle"/>
+          </a:ln>
+        </p:spPr>
+        <p:style>
+          <a:lnRef idx="2">
+            <a:schemeClr val="accent1"/>
+          </a:lnRef>
+          <a:fillRef idx="0">
+            <a:schemeClr val="accent1"/>
+          </a:fillRef>
+          <a:effectRef idx="1">
+            <a:schemeClr val="accent1"/>
+          </a:effectRef>
+          <a:fontRef idx="minor">
+            <a:schemeClr val="tx1"/>
+          </a:fontRef>
+        </p:style>
+      </p:cxnSp>
+      <p:sp>
+        <p:nvSpPr>
+          <p:cNvPr id="8" name="TextBox 7">
+            <a:extLst>
+              <a:ext uri="{FF2B5EF4-FFF2-40B4-BE49-F238E27FC236}">
+                <a16:creationId xmlns:a16="http://schemas.microsoft.com/office/drawing/2014/main" id="{673BAD96-2023-8280-911F-1A9EDD8B7850}"/>
+              </a:ext>
+            </a:extLst>
+          </p:cNvPr>
+          <p:cNvSpPr txBox="1"/>
+          <p:nvPr/>
+        </p:nvSpPr>
+        <p:spPr>
+          <a:xfrm>
+            <a:off x="566200" y="2598003"/>
+            <a:ext cx="3126056" cy="830997"/>
+          </a:xfrm>
+          <a:prstGeom prst="rect">
+            <a:avLst/>
+          </a:prstGeom>
+          <a:noFill/>
+        </p:spPr>
+        <p:txBody>
+          <a:bodyPr wrap="square" rtlCol="0">
+            <a:spAutoFit/>
+          </a:bodyPr>
+          <a:lstStyle/>
+          <a:p>
+            <a:pPr algn="ctr"/>
+            <a:r>
+              <a:rPr lang="en-US" sz="1600" dirty="0"/>
+              <a:t>Update git tree (git fetch) and merge changes to my work directory (git merge)</a:t>
+            </a:r>
+          </a:p>
+        </p:txBody>
+      </p:sp>
+      <p:sp>
+        <p:nvSpPr>
+          <p:cNvPr id="11" name="TextBox 10">
+            <a:extLst>
+              <a:ext uri="{FF2B5EF4-FFF2-40B4-BE49-F238E27FC236}">
+                <a16:creationId xmlns:a16="http://schemas.microsoft.com/office/drawing/2014/main" id="{94FF8A8F-9085-5403-0D72-893A89C455A0}"/>
+              </a:ext>
+            </a:extLst>
+          </p:cNvPr>
+          <p:cNvSpPr txBox="1"/>
+          <p:nvPr/>
+        </p:nvSpPr>
+        <p:spPr>
+          <a:xfrm>
+            <a:off x="924560" y="4444583"/>
+            <a:ext cx="3126056" cy="830997"/>
+          </a:xfrm>
+          <a:prstGeom prst="rect">
+            <a:avLst/>
+          </a:prstGeom>
+          <a:noFill/>
+        </p:spPr>
+        <p:txBody>
+          <a:bodyPr wrap="square" rtlCol="0">
+            <a:spAutoFit/>
+          </a:bodyPr>
+          <a:lstStyle/>
+          <a:p>
+            <a:pPr algn="ctr"/>
+            <a:r>
+              <a:rPr lang="en-US" sz="1600" dirty="0"/>
+              <a:t>Branch updates with last commit the branch points at in remote repo</a:t>
+            </a:r>
+          </a:p>
+        </p:txBody>
+      </p:sp>
+      <p:sp>
+        <p:nvSpPr>
+          <p:cNvPr id="12" name="Rectangle 11">
+            <a:extLst>
+              <a:ext uri="{FF2B5EF4-FFF2-40B4-BE49-F238E27FC236}">
+                <a16:creationId xmlns:a16="http://schemas.microsoft.com/office/drawing/2014/main" id="{066BFA80-5F33-08DE-7457-B0D4296E1E2D}"/>
+              </a:ext>
+            </a:extLst>
+          </p:cNvPr>
+          <p:cNvSpPr/>
+          <p:nvPr/>
+        </p:nvSpPr>
+        <p:spPr>
+          <a:xfrm>
+            <a:off x="8366074" y="4195284"/>
+            <a:ext cx="3546525" cy="206614"/>
+          </a:xfrm>
+          <a:prstGeom prst="rect">
+            <a:avLst/>
+          </a:prstGeom>
+          <a:noFill/>
+          <a:ln>
+            <a:solidFill>
+              <a:srgbClr val="FF0000"/>
+            </a:solidFill>
+          </a:ln>
+        </p:spPr>
+        <p:style>
+          <a:lnRef idx="2">
+            <a:schemeClr val="accent1">
+              <a:shade val="15000"/>
+            </a:schemeClr>
+          </a:lnRef>
+          <a:fillRef idx="1">
+            <a:schemeClr val="accent1"/>
+          </a:fillRef>
+          <a:effectRef idx="0">
+            <a:schemeClr val="accent1"/>
+          </a:effectRef>
+          <a:fontRef idx="minor">
+            <a:schemeClr val="lt1"/>
+          </a:fontRef>
+        </p:style>
+        <p:txBody>
+          <a:bodyPr rtlCol="0" anchor="ctr"/>
+          <a:lstStyle/>
+          <a:p>
+            <a:pPr algn="ctr"/>
+            <a:endParaRPr lang="en-US" dirty="0"/>
+          </a:p>
+        </p:txBody>
+      </p:sp>
+      <p:cxnSp>
+        <p:nvCxnSpPr>
+          <p:cNvPr id="13" name="Straight Arrow Connector 12">
+            <a:extLst>
+              <a:ext uri="{FF2B5EF4-FFF2-40B4-BE49-F238E27FC236}">
+                <a16:creationId xmlns:a16="http://schemas.microsoft.com/office/drawing/2014/main" id="{7FE26DC9-9374-E295-80DB-B05A33A108ED}"/>
+              </a:ext>
+            </a:extLst>
+          </p:cNvPr>
+          <p:cNvCxnSpPr>
+            <a:cxnSpLocks/>
+            <a:stCxn id="11" idx="3"/>
+            <a:endCxn id="12" idx="1"/>
+          </p:cNvCxnSpPr>
+          <p:nvPr/>
+        </p:nvCxnSpPr>
+        <p:spPr>
+          <a:xfrm flipV="1">
+            <a:off x="4050616" y="4298591"/>
+            <a:ext cx="4315458" cy="561491"/>
+          </a:xfrm>
+          <a:prstGeom prst="straightConnector1">
+            <a:avLst/>
+          </a:prstGeom>
+          <a:ln w="57150">
+            <a:solidFill>
+              <a:srgbClr val="FF0000"/>
+            </a:solidFill>
+            <a:tailEnd type="triangle"/>
+          </a:ln>
+        </p:spPr>
+        <p:style>
+          <a:lnRef idx="2">
+            <a:schemeClr val="accent1"/>
+          </a:lnRef>
+          <a:fillRef idx="0">
+            <a:schemeClr val="accent1"/>
+          </a:fillRef>
+          <a:effectRef idx="1">
+            <a:schemeClr val="accent1"/>
+          </a:effectRef>
+          <a:fontRef idx="minor">
+            <a:schemeClr val="tx1"/>
+          </a:fontRef>
+        </p:style>
+      </p:cxnSp>
+      <p:sp>
+        <p:nvSpPr>
+          <p:cNvPr id="17" name="TextBox 16">
+            <a:extLst>
+              <a:ext uri="{FF2B5EF4-FFF2-40B4-BE49-F238E27FC236}">
+                <a16:creationId xmlns:a16="http://schemas.microsoft.com/office/drawing/2014/main" id="{54037028-3858-4AC4-C65E-71D1FDFA54E3}"/>
+              </a:ext>
+            </a:extLst>
+          </p:cNvPr>
+          <p:cNvSpPr txBox="1"/>
+          <p:nvPr/>
+        </p:nvSpPr>
+        <p:spPr>
+          <a:xfrm>
+            <a:off x="10837672" y="6386678"/>
+            <a:ext cx="1191768" cy="369332"/>
+          </a:xfrm>
+          <a:prstGeom prst="rect">
+            <a:avLst/>
+          </a:prstGeom>
+          <a:noFill/>
+        </p:spPr>
+        <p:txBody>
+          <a:bodyPr wrap="square">
+            <a:spAutoFit/>
+          </a:bodyPr>
+          <a:lstStyle/>
+          <a:p>
+            <a:r>
+              <a:rPr lang="en-US" b="1" dirty="0"/>
+              <a:t>&gt; git pull</a:t>
+            </a:r>
+          </a:p>
+        </p:txBody>
+      </p:sp>
     </p:spTree>
     <p:extLst>
       <p:ext uri="{BB962C8B-B14F-4D97-AF65-F5344CB8AC3E}">
@@ -11661,7 +12917,7 @@
         </p:blipFill>
         <p:spPr>
           <a:xfrm>
-            <a:off x="4584193" y="1866932"/>
+            <a:off x="4728973" y="1485932"/>
             <a:ext cx="6769607" cy="4717381"/>
           </a:xfrm>
           <a:prstGeom prst="rect">
@@ -11669,6 +12925,139 @@
           </a:prstGeom>
         </p:spPr>
       </p:pic>
+      <p:sp>
+        <p:nvSpPr>
+          <p:cNvPr id="6" name="Rectangle 5">
+            <a:extLst>
+              <a:ext uri="{FF2B5EF4-FFF2-40B4-BE49-F238E27FC236}">
+                <a16:creationId xmlns:a16="http://schemas.microsoft.com/office/drawing/2014/main" id="{56F7223F-40B1-DD12-CD7C-BD28B81CEEFE}"/>
+              </a:ext>
+            </a:extLst>
+          </p:cNvPr>
+          <p:cNvSpPr/>
+          <p:nvPr/>
+        </p:nvSpPr>
+        <p:spPr>
+          <a:xfrm>
+            <a:off x="9865900" y="2041038"/>
+            <a:ext cx="1343120" cy="397362"/>
+          </a:xfrm>
+          <a:prstGeom prst="rect">
+            <a:avLst/>
+          </a:prstGeom>
+          <a:noFill/>
+          <a:ln>
+            <a:solidFill>
+              <a:srgbClr val="FF0000"/>
+            </a:solidFill>
+          </a:ln>
+        </p:spPr>
+        <p:style>
+          <a:lnRef idx="2">
+            <a:schemeClr val="accent1">
+              <a:shade val="15000"/>
+            </a:schemeClr>
+          </a:lnRef>
+          <a:fillRef idx="1">
+            <a:schemeClr val="accent1"/>
+          </a:fillRef>
+          <a:effectRef idx="0">
+            <a:schemeClr val="accent1"/>
+          </a:effectRef>
+          <a:fontRef idx="minor">
+            <a:schemeClr val="lt1"/>
+          </a:fontRef>
+        </p:style>
+        <p:txBody>
+          <a:bodyPr rtlCol="0" anchor="ctr"/>
+          <a:lstStyle/>
+          <a:p>
+            <a:pPr algn="ctr"/>
+            <a:endParaRPr lang="en-US" dirty="0"/>
+          </a:p>
+        </p:txBody>
+      </p:sp>
+      <p:cxnSp>
+        <p:nvCxnSpPr>
+          <p:cNvPr id="7" name="Straight Arrow Connector 6">
+            <a:extLst>
+              <a:ext uri="{FF2B5EF4-FFF2-40B4-BE49-F238E27FC236}">
+                <a16:creationId xmlns:a16="http://schemas.microsoft.com/office/drawing/2014/main" id="{78ACD3AA-F3B1-98F0-CB5E-34E392B1F649}"/>
+              </a:ext>
+            </a:extLst>
+          </p:cNvPr>
+          <p:cNvCxnSpPr>
+            <a:cxnSpLocks/>
+            <a:stCxn id="8" idx="3"/>
+          </p:cNvCxnSpPr>
+          <p:nvPr/>
+        </p:nvCxnSpPr>
+        <p:spPr>
+          <a:xfrm flipV="1">
+            <a:off x="3692256" y="2211111"/>
+            <a:ext cx="6173644" cy="556169"/>
+          </a:xfrm>
+          <a:prstGeom prst="straightConnector1">
+            <a:avLst/>
+          </a:prstGeom>
+          <a:ln w="57150">
+            <a:solidFill>
+              <a:srgbClr val="FF0000"/>
+            </a:solidFill>
+            <a:tailEnd type="triangle"/>
+          </a:ln>
+        </p:spPr>
+        <p:style>
+          <a:lnRef idx="2">
+            <a:schemeClr val="accent1"/>
+          </a:lnRef>
+          <a:fillRef idx="0">
+            <a:schemeClr val="accent1"/>
+          </a:fillRef>
+          <a:effectRef idx="1">
+            <a:schemeClr val="accent1"/>
+          </a:effectRef>
+          <a:fontRef idx="minor">
+            <a:schemeClr val="tx1"/>
+          </a:fontRef>
+        </p:style>
+      </p:cxnSp>
+      <p:sp>
+        <p:nvSpPr>
+          <p:cNvPr id="8" name="TextBox 7">
+            <a:extLst>
+              <a:ext uri="{FF2B5EF4-FFF2-40B4-BE49-F238E27FC236}">
+                <a16:creationId xmlns:a16="http://schemas.microsoft.com/office/drawing/2014/main" id="{6982AABF-9C04-DCA3-4AF0-3EF7BC122723}"/>
+              </a:ext>
+            </a:extLst>
+          </p:cNvPr>
+          <p:cNvSpPr txBox="1"/>
+          <p:nvPr/>
+        </p:nvSpPr>
+        <p:spPr>
+          <a:xfrm>
+            <a:off x="566200" y="2598003"/>
+            <a:ext cx="3126056" cy="338554"/>
+          </a:xfrm>
+          <a:prstGeom prst="rect">
+            <a:avLst/>
+          </a:prstGeom>
+          <a:noFill/>
+        </p:spPr>
+        <p:txBody>
+          <a:bodyPr wrap="square" rtlCol="0">
+            <a:spAutoFit/>
+          </a:bodyPr>
+          <a:lstStyle/>
+          <a:p>
+            <a:pPr algn="ctr"/>
+            <a:r>
+              <a:rPr lang="en-US" sz="1600" dirty="0"/>
+              <a:t>Click to create pull request</a:t>
+            </a:r>
+          </a:p>
+        </p:txBody>
+      </p:sp>
     </p:spTree>
     <p:extLst>
       <p:ext uri="{BB962C8B-B14F-4D97-AF65-F5344CB8AC3E}">
@@ -11762,6 +13151,250 @@
           </a:prstGeom>
         </p:spPr>
       </p:pic>
+      <p:sp>
+        <p:nvSpPr>
+          <p:cNvPr id="6" name="Rectangle 5">
+            <a:extLst>
+              <a:ext uri="{FF2B5EF4-FFF2-40B4-BE49-F238E27FC236}">
+                <a16:creationId xmlns:a16="http://schemas.microsoft.com/office/drawing/2014/main" id="{9C653450-AC50-64AF-9037-E5A0C4502ABD}"/>
+              </a:ext>
+            </a:extLst>
+          </p:cNvPr>
+          <p:cNvSpPr/>
+          <p:nvPr/>
+        </p:nvSpPr>
+        <p:spPr>
+          <a:xfrm>
+            <a:off x="4547140" y="2012430"/>
+            <a:ext cx="1343120" cy="397362"/>
+          </a:xfrm>
+          <a:prstGeom prst="rect">
+            <a:avLst/>
+          </a:prstGeom>
+          <a:noFill/>
+          <a:ln>
+            <a:solidFill>
+              <a:srgbClr val="FF0000"/>
+            </a:solidFill>
+          </a:ln>
+        </p:spPr>
+        <p:style>
+          <a:lnRef idx="2">
+            <a:schemeClr val="accent1">
+              <a:shade val="15000"/>
+            </a:schemeClr>
+          </a:lnRef>
+          <a:fillRef idx="1">
+            <a:schemeClr val="accent1"/>
+          </a:fillRef>
+          <a:effectRef idx="0">
+            <a:schemeClr val="accent1"/>
+          </a:effectRef>
+          <a:fontRef idx="minor">
+            <a:schemeClr val="lt1"/>
+          </a:fontRef>
+        </p:style>
+        <p:txBody>
+          <a:bodyPr rtlCol="0" anchor="ctr"/>
+          <a:lstStyle/>
+          <a:p>
+            <a:pPr algn="ctr"/>
+            <a:endParaRPr lang="en-US" dirty="0"/>
+          </a:p>
+        </p:txBody>
+      </p:sp>
+      <p:sp>
+        <p:nvSpPr>
+          <p:cNvPr id="8" name="TextBox 7">
+            <a:extLst>
+              <a:ext uri="{FF2B5EF4-FFF2-40B4-BE49-F238E27FC236}">
+                <a16:creationId xmlns:a16="http://schemas.microsoft.com/office/drawing/2014/main" id="{9479FEFB-E051-D1FF-22C7-3E240480244B}"/>
+              </a:ext>
+            </a:extLst>
+          </p:cNvPr>
+          <p:cNvSpPr txBox="1"/>
+          <p:nvPr/>
+        </p:nvSpPr>
+        <p:spPr>
+          <a:xfrm>
+            <a:off x="566200" y="2598003"/>
+            <a:ext cx="3126056" cy="584775"/>
+          </a:xfrm>
+          <a:prstGeom prst="rect">
+            <a:avLst/>
+          </a:prstGeom>
+          <a:noFill/>
+        </p:spPr>
+        <p:txBody>
+          <a:bodyPr wrap="square" rtlCol="0">
+            <a:spAutoFit/>
+          </a:bodyPr>
+          <a:lstStyle/>
+          <a:p>
+            <a:pPr algn="ctr"/>
+            <a:r>
+              <a:rPr lang="en-US" sz="1600" dirty="0"/>
+              <a:t>Fill mandatory fields and create pull request</a:t>
+            </a:r>
+          </a:p>
+        </p:txBody>
+      </p:sp>
+      <p:sp>
+        <p:nvSpPr>
+          <p:cNvPr id="9" name="Rectangle 8">
+            <a:extLst>
+              <a:ext uri="{FF2B5EF4-FFF2-40B4-BE49-F238E27FC236}">
+                <a16:creationId xmlns:a16="http://schemas.microsoft.com/office/drawing/2014/main" id="{051434E6-91C0-7AAA-E81F-4A8C0B95673E}"/>
+              </a:ext>
+            </a:extLst>
+          </p:cNvPr>
+          <p:cNvSpPr/>
+          <p:nvPr/>
+        </p:nvSpPr>
+        <p:spPr>
+          <a:xfrm>
+            <a:off x="4547140" y="2432235"/>
+            <a:ext cx="1343120" cy="744880"/>
+          </a:xfrm>
+          <a:prstGeom prst="rect">
+            <a:avLst/>
+          </a:prstGeom>
+          <a:noFill/>
+          <a:ln>
+            <a:solidFill>
+              <a:srgbClr val="FF0000"/>
+            </a:solidFill>
+          </a:ln>
+        </p:spPr>
+        <p:style>
+          <a:lnRef idx="2">
+            <a:schemeClr val="accent1">
+              <a:shade val="15000"/>
+            </a:schemeClr>
+          </a:lnRef>
+          <a:fillRef idx="1">
+            <a:schemeClr val="accent1"/>
+          </a:fillRef>
+          <a:effectRef idx="0">
+            <a:schemeClr val="accent1"/>
+          </a:effectRef>
+          <a:fontRef idx="minor">
+            <a:schemeClr val="lt1"/>
+          </a:fontRef>
+        </p:style>
+        <p:txBody>
+          <a:bodyPr rtlCol="0" anchor="ctr"/>
+          <a:lstStyle/>
+          <a:p>
+            <a:pPr algn="ctr"/>
+            <a:endParaRPr lang="en-US" dirty="0"/>
+          </a:p>
+        </p:txBody>
+      </p:sp>
+      <p:sp>
+        <p:nvSpPr>
+          <p:cNvPr id="10" name="Rectangle 9">
+            <a:extLst>
+              <a:ext uri="{FF2B5EF4-FFF2-40B4-BE49-F238E27FC236}">
+                <a16:creationId xmlns:a16="http://schemas.microsoft.com/office/drawing/2014/main" id="{B4ACB5EA-ECAA-53A9-F985-4D049AFD37D9}"/>
+              </a:ext>
+            </a:extLst>
+          </p:cNvPr>
+          <p:cNvSpPr/>
+          <p:nvPr/>
+        </p:nvSpPr>
+        <p:spPr>
+          <a:xfrm>
+            <a:off x="9736360" y="2200641"/>
+            <a:ext cx="1863800" cy="735916"/>
+          </a:xfrm>
+          <a:prstGeom prst="rect">
+            <a:avLst/>
+          </a:prstGeom>
+          <a:noFill/>
+          <a:ln>
+            <a:solidFill>
+              <a:srgbClr val="FF0000"/>
+            </a:solidFill>
+          </a:ln>
+        </p:spPr>
+        <p:style>
+          <a:lnRef idx="2">
+            <a:schemeClr val="accent1">
+              <a:shade val="15000"/>
+            </a:schemeClr>
+          </a:lnRef>
+          <a:fillRef idx="1">
+            <a:schemeClr val="accent1"/>
+          </a:fillRef>
+          <a:effectRef idx="0">
+            <a:schemeClr val="accent1"/>
+          </a:effectRef>
+          <a:fontRef idx="minor">
+            <a:schemeClr val="lt1"/>
+          </a:fontRef>
+        </p:style>
+        <p:txBody>
+          <a:bodyPr rtlCol="0" anchor="ctr"/>
+          <a:lstStyle/>
+          <a:p>
+            <a:pPr algn="ctr"/>
+            <a:endParaRPr lang="en-US" dirty="0"/>
+          </a:p>
+        </p:txBody>
+      </p:sp>
+      <p:sp>
+        <p:nvSpPr>
+          <p:cNvPr id="11" name="Rectangle 10">
+            <a:extLst>
+              <a:ext uri="{FF2B5EF4-FFF2-40B4-BE49-F238E27FC236}">
+                <a16:creationId xmlns:a16="http://schemas.microsoft.com/office/drawing/2014/main" id="{0A8B38E0-C595-60AA-D12B-84EB9F31F67A}"/>
+              </a:ext>
+            </a:extLst>
+          </p:cNvPr>
+          <p:cNvSpPr/>
+          <p:nvPr/>
+        </p:nvSpPr>
+        <p:spPr>
+          <a:xfrm>
+            <a:off x="8341900" y="4623801"/>
+            <a:ext cx="1394460" cy="420639"/>
+          </a:xfrm>
+          <a:prstGeom prst="rect">
+            <a:avLst/>
+          </a:prstGeom>
+          <a:noFill/>
+          <a:ln>
+            <a:solidFill>
+              <a:srgbClr val="FF0000"/>
+            </a:solidFill>
+          </a:ln>
+        </p:spPr>
+        <p:style>
+          <a:lnRef idx="2">
+            <a:schemeClr val="accent1">
+              <a:shade val="15000"/>
+            </a:schemeClr>
+          </a:lnRef>
+          <a:fillRef idx="1">
+            <a:schemeClr val="accent1"/>
+          </a:fillRef>
+          <a:effectRef idx="0">
+            <a:schemeClr val="accent1"/>
+          </a:effectRef>
+          <a:fontRef idx="minor">
+            <a:schemeClr val="lt1"/>
+          </a:fontRef>
+        </p:style>
+        <p:txBody>
+          <a:bodyPr rtlCol="0" anchor="ctr"/>
+          <a:lstStyle/>
+          <a:p>
+            <a:pPr algn="ctr"/>
+            <a:endParaRPr lang="en-US" dirty="0"/>
+          </a:p>
+        </p:txBody>
+      </p:sp>
     </p:spTree>
     <p:extLst>
       <p:ext uri="{BB962C8B-B14F-4D97-AF65-F5344CB8AC3E}">
@@ -11792,45 +13425,12 @@
           <a:chExt cx="0" cy="0"/>
         </a:xfrm>
       </p:grpSpPr>
-      <p:sp>
-        <p:nvSpPr>
-          <p:cNvPr id="2" name="Title 1">
-            <a:extLst>
-              <a:ext uri="{FF2B5EF4-FFF2-40B4-BE49-F238E27FC236}">
-                <a16:creationId xmlns:a16="http://schemas.microsoft.com/office/drawing/2014/main" id="{8D2CE99F-8423-A4AF-AF5A-27D09238EE71}"/>
-              </a:ext>
-            </a:extLst>
-          </p:cNvPr>
-          <p:cNvSpPr>
-            <a:spLocks noGrp="1"/>
-          </p:cNvSpPr>
-          <p:nvPr>
-            <p:ph type="title"/>
-          </p:nvPr>
-        </p:nvSpPr>
-        <p:spPr/>
-        <p:txBody>
-          <a:bodyPr/>
-          <a:lstStyle/>
-          <a:p>
-            <a:r>
-              <a:rPr lang="en-US" dirty="0"/>
-              <a:t>07 - </a:t>
-            </a:r>
-            <a:r>
-              <a:rPr lang="en-US" dirty="0" err="1"/>
-              <a:t>Github</a:t>
-            </a:r>
-            <a:endParaRPr lang="en-US" dirty="0"/>
-          </a:p>
-        </p:txBody>
-      </p:sp>
       <p:pic>
         <p:nvPicPr>
-          <p:cNvPr id="5" name="Picture 4">
-            <a:extLst>
-              <a:ext uri="{FF2B5EF4-FFF2-40B4-BE49-F238E27FC236}">
-                <a16:creationId xmlns:a16="http://schemas.microsoft.com/office/drawing/2014/main" id="{6F067EF9-411B-1830-0474-6516A4A3239E}"/>
+          <p:cNvPr id="13" name="Picture 12">
+            <a:extLst>
+              <a:ext uri="{FF2B5EF4-FFF2-40B4-BE49-F238E27FC236}">
+                <a16:creationId xmlns:a16="http://schemas.microsoft.com/office/drawing/2014/main" id="{8D93C010-FE24-BDA9-CA54-A7E2FD633B43}"/>
               </a:ext>
             </a:extLst>
           </p:cNvPr>
@@ -11847,14 +13447,350 @@
         </p:blipFill>
         <p:spPr>
           <a:xfrm>
-            <a:off x="2269754" y="2423346"/>
-            <a:ext cx="9678239" cy="2461473"/>
+            <a:off x="2224620" y="2316609"/>
+            <a:ext cx="9693480" cy="3322608"/>
           </a:xfrm>
           <a:prstGeom prst="rect">
             <a:avLst/>
           </a:prstGeom>
         </p:spPr>
       </p:pic>
+      <p:sp>
+        <p:nvSpPr>
+          <p:cNvPr id="2" name="Title 1">
+            <a:extLst>
+              <a:ext uri="{FF2B5EF4-FFF2-40B4-BE49-F238E27FC236}">
+                <a16:creationId xmlns:a16="http://schemas.microsoft.com/office/drawing/2014/main" id="{8D2CE99F-8423-A4AF-AF5A-27D09238EE71}"/>
+              </a:ext>
+            </a:extLst>
+          </p:cNvPr>
+          <p:cNvSpPr>
+            <a:spLocks noGrp="1"/>
+          </p:cNvSpPr>
+          <p:nvPr>
+            <p:ph type="title"/>
+          </p:nvPr>
+        </p:nvSpPr>
+        <p:spPr/>
+        <p:txBody>
+          <a:bodyPr/>
+          <a:lstStyle/>
+          <a:p>
+            <a:r>
+              <a:rPr lang="en-US" dirty="0"/>
+              <a:t>07 - </a:t>
+            </a:r>
+            <a:r>
+              <a:rPr lang="en-US" dirty="0" err="1"/>
+              <a:t>Github</a:t>
+            </a:r>
+            <a:endParaRPr lang="en-US" dirty="0"/>
+          </a:p>
+        </p:txBody>
+      </p:sp>
+      <p:sp>
+        <p:nvSpPr>
+          <p:cNvPr id="6" name="Rectangle 5">
+            <a:extLst>
+              <a:ext uri="{FF2B5EF4-FFF2-40B4-BE49-F238E27FC236}">
+                <a16:creationId xmlns:a16="http://schemas.microsoft.com/office/drawing/2014/main" id="{312534AD-093B-CD2D-C1BB-E6CAAD04ABC2}"/>
+              </a:ext>
+            </a:extLst>
+          </p:cNvPr>
+          <p:cNvSpPr/>
+          <p:nvPr/>
+        </p:nvSpPr>
+        <p:spPr>
+          <a:xfrm>
+            <a:off x="4613180" y="2362386"/>
+            <a:ext cx="2498820" cy="236034"/>
+          </a:xfrm>
+          <a:prstGeom prst="rect">
+            <a:avLst/>
+          </a:prstGeom>
+          <a:noFill/>
+          <a:ln>
+            <a:solidFill>
+              <a:srgbClr val="FF0000"/>
+            </a:solidFill>
+          </a:ln>
+        </p:spPr>
+        <p:style>
+          <a:lnRef idx="2">
+            <a:schemeClr val="accent1">
+              <a:shade val="15000"/>
+            </a:schemeClr>
+          </a:lnRef>
+          <a:fillRef idx="1">
+            <a:schemeClr val="accent1"/>
+          </a:fillRef>
+          <a:effectRef idx="0">
+            <a:schemeClr val="accent1"/>
+          </a:effectRef>
+          <a:fontRef idx="minor">
+            <a:schemeClr val="lt1"/>
+          </a:fontRef>
+        </p:style>
+        <p:txBody>
+          <a:bodyPr rtlCol="0" anchor="ctr"/>
+          <a:lstStyle/>
+          <a:p>
+            <a:pPr algn="ctr"/>
+            <a:endParaRPr lang="en-US" dirty="0"/>
+          </a:p>
+        </p:txBody>
+      </p:sp>
+      <p:cxnSp>
+        <p:nvCxnSpPr>
+          <p:cNvPr id="7" name="Straight Arrow Connector 6">
+            <a:extLst>
+              <a:ext uri="{FF2B5EF4-FFF2-40B4-BE49-F238E27FC236}">
+                <a16:creationId xmlns:a16="http://schemas.microsoft.com/office/drawing/2014/main" id="{1903762B-9389-3378-8238-55B5178F0F4B}"/>
+              </a:ext>
+            </a:extLst>
+          </p:cNvPr>
+          <p:cNvCxnSpPr>
+            <a:cxnSpLocks/>
+            <a:stCxn id="8" idx="2"/>
+            <a:endCxn id="6" idx="0"/>
+          </p:cNvCxnSpPr>
+          <p:nvPr/>
+        </p:nvCxnSpPr>
+        <p:spPr>
+          <a:xfrm flipH="1">
+            <a:off x="5862590" y="1811178"/>
+            <a:ext cx="935610" cy="551208"/>
+          </a:xfrm>
+          <a:prstGeom prst="straightConnector1">
+            <a:avLst/>
+          </a:prstGeom>
+          <a:ln w="57150">
+            <a:solidFill>
+              <a:srgbClr val="FF0000"/>
+            </a:solidFill>
+            <a:tailEnd type="triangle"/>
+          </a:ln>
+        </p:spPr>
+        <p:style>
+          <a:lnRef idx="2">
+            <a:schemeClr val="accent1"/>
+          </a:lnRef>
+          <a:fillRef idx="0">
+            <a:schemeClr val="accent1"/>
+          </a:fillRef>
+          <a:effectRef idx="1">
+            <a:schemeClr val="accent1"/>
+          </a:effectRef>
+          <a:fontRef idx="minor">
+            <a:schemeClr val="tx1"/>
+          </a:fontRef>
+        </p:style>
+      </p:cxnSp>
+      <p:sp>
+        <p:nvSpPr>
+          <p:cNvPr id="8" name="TextBox 7">
+            <a:extLst>
+              <a:ext uri="{FF2B5EF4-FFF2-40B4-BE49-F238E27FC236}">
+                <a16:creationId xmlns:a16="http://schemas.microsoft.com/office/drawing/2014/main" id="{9A88BA8A-F5D6-0AD4-957D-E17BB6BE2A7D}"/>
+              </a:ext>
+            </a:extLst>
+          </p:cNvPr>
+          <p:cNvSpPr txBox="1"/>
+          <p:nvPr/>
+        </p:nvSpPr>
+        <p:spPr>
+          <a:xfrm>
+            <a:off x="5473480" y="1226403"/>
+            <a:ext cx="2649440" cy="584775"/>
+          </a:xfrm>
+          <a:prstGeom prst="rect">
+            <a:avLst/>
+          </a:prstGeom>
+          <a:noFill/>
+        </p:spPr>
+        <p:txBody>
+          <a:bodyPr wrap="square" rtlCol="0">
+            <a:spAutoFit/>
+          </a:bodyPr>
+          <a:lstStyle/>
+          <a:p>
+            <a:pPr algn="ctr"/>
+            <a:r>
+              <a:rPr lang="en-US" sz="1600" dirty="0"/>
+              <a:t>Go to branch you want to get updated</a:t>
+            </a:r>
+          </a:p>
+        </p:txBody>
+      </p:sp>
+      <p:sp>
+        <p:nvSpPr>
+          <p:cNvPr id="17" name="TextBox 16">
+            <a:extLst>
+              <a:ext uri="{FF2B5EF4-FFF2-40B4-BE49-F238E27FC236}">
+                <a16:creationId xmlns:a16="http://schemas.microsoft.com/office/drawing/2014/main" id="{67AEEA62-80D3-AFEC-069F-DD87487B64E5}"/>
+              </a:ext>
+            </a:extLst>
+          </p:cNvPr>
+          <p:cNvSpPr txBox="1"/>
+          <p:nvPr/>
+        </p:nvSpPr>
+        <p:spPr>
+          <a:xfrm>
+            <a:off x="9462052" y="5717443"/>
+            <a:ext cx="2487632" cy="369332"/>
+          </a:xfrm>
+          <a:prstGeom prst="rect">
+            <a:avLst/>
+          </a:prstGeom>
+          <a:noFill/>
+        </p:spPr>
+        <p:txBody>
+          <a:bodyPr wrap="square">
+            <a:spAutoFit/>
+          </a:bodyPr>
+          <a:lstStyle/>
+          <a:p>
+            <a:r>
+              <a:rPr lang="en-US" b="1" dirty="0"/>
+              <a:t>&gt; git merge &lt;branch&gt;</a:t>
+            </a:r>
+          </a:p>
+        </p:txBody>
+      </p:sp>
+      <p:sp>
+        <p:nvSpPr>
+          <p:cNvPr id="18" name="Rectangle 17">
+            <a:extLst>
+              <a:ext uri="{FF2B5EF4-FFF2-40B4-BE49-F238E27FC236}">
+                <a16:creationId xmlns:a16="http://schemas.microsoft.com/office/drawing/2014/main" id="{21907574-41DD-AAF4-7151-368AC0556296}"/>
+              </a:ext>
+            </a:extLst>
+          </p:cNvPr>
+          <p:cNvSpPr/>
+          <p:nvPr/>
+        </p:nvSpPr>
+        <p:spPr>
+          <a:xfrm>
+            <a:off x="4572540" y="3093069"/>
+            <a:ext cx="1381220" cy="236034"/>
+          </a:xfrm>
+          <a:prstGeom prst="rect">
+            <a:avLst/>
+          </a:prstGeom>
+          <a:noFill/>
+          <a:ln>
+            <a:solidFill>
+              <a:srgbClr val="FF0000"/>
+            </a:solidFill>
+          </a:ln>
+        </p:spPr>
+        <p:style>
+          <a:lnRef idx="2">
+            <a:schemeClr val="accent1">
+              <a:shade val="15000"/>
+            </a:schemeClr>
+          </a:lnRef>
+          <a:fillRef idx="1">
+            <a:schemeClr val="accent1"/>
+          </a:fillRef>
+          <a:effectRef idx="0">
+            <a:schemeClr val="accent1"/>
+          </a:effectRef>
+          <a:fontRef idx="minor">
+            <a:schemeClr val="lt1"/>
+          </a:fontRef>
+        </p:style>
+        <p:txBody>
+          <a:bodyPr rtlCol="0" anchor="ctr"/>
+          <a:lstStyle/>
+          <a:p>
+            <a:pPr algn="ctr"/>
+            <a:endParaRPr lang="en-US" dirty="0"/>
+          </a:p>
+        </p:txBody>
+      </p:sp>
+      <p:sp>
+        <p:nvSpPr>
+          <p:cNvPr id="20" name="TextBox 19">
+            <a:extLst>
+              <a:ext uri="{FF2B5EF4-FFF2-40B4-BE49-F238E27FC236}">
+                <a16:creationId xmlns:a16="http://schemas.microsoft.com/office/drawing/2014/main" id="{1B33A11D-8908-7532-3D9B-AC008C8ECD4D}"/>
+              </a:ext>
+            </a:extLst>
+          </p:cNvPr>
+          <p:cNvSpPr txBox="1"/>
+          <p:nvPr/>
+        </p:nvSpPr>
+        <p:spPr>
+          <a:xfrm>
+            <a:off x="8155388" y="1653608"/>
+            <a:ext cx="2649440" cy="584775"/>
+          </a:xfrm>
+          <a:prstGeom prst="rect">
+            <a:avLst/>
+          </a:prstGeom>
+          <a:noFill/>
+        </p:spPr>
+        <p:txBody>
+          <a:bodyPr wrap="square" rtlCol="0">
+            <a:spAutoFit/>
+          </a:bodyPr>
+          <a:lstStyle/>
+          <a:p>
+            <a:pPr algn="ctr"/>
+            <a:r>
+              <a:rPr lang="en-US" sz="1600" dirty="0"/>
+              <a:t>Merge main branch to source-content</a:t>
+            </a:r>
+          </a:p>
+        </p:txBody>
+      </p:sp>
+      <p:cxnSp>
+        <p:nvCxnSpPr>
+          <p:cNvPr id="21" name="Straight Arrow Connector 20">
+            <a:extLst>
+              <a:ext uri="{FF2B5EF4-FFF2-40B4-BE49-F238E27FC236}">
+                <a16:creationId xmlns:a16="http://schemas.microsoft.com/office/drawing/2014/main" id="{07C0B030-17B7-30D8-A111-3E220A2DF60F}"/>
+              </a:ext>
+            </a:extLst>
+          </p:cNvPr>
+          <p:cNvCxnSpPr>
+            <a:cxnSpLocks/>
+            <a:stCxn id="20" idx="2"/>
+            <a:endCxn id="18" idx="3"/>
+          </p:cNvCxnSpPr>
+          <p:nvPr/>
+        </p:nvCxnSpPr>
+        <p:spPr>
+          <a:xfrm flipH="1">
+            <a:off x="5953760" y="2238383"/>
+            <a:ext cx="3526348" cy="972703"/>
+          </a:xfrm>
+          <a:prstGeom prst="straightConnector1">
+            <a:avLst/>
+          </a:prstGeom>
+          <a:ln w="57150">
+            <a:solidFill>
+              <a:srgbClr val="FF0000"/>
+            </a:solidFill>
+            <a:tailEnd type="triangle"/>
+          </a:ln>
+        </p:spPr>
+        <p:style>
+          <a:lnRef idx="2">
+            <a:schemeClr val="accent1"/>
+          </a:lnRef>
+          <a:fillRef idx="0">
+            <a:schemeClr val="accent1"/>
+          </a:fillRef>
+          <a:effectRef idx="1">
+            <a:schemeClr val="accent1"/>
+          </a:effectRef>
+          <a:fontRef idx="minor">
+            <a:schemeClr val="tx1"/>
+          </a:fontRef>
+        </p:style>
+      </p:cxnSp>
     </p:spTree>
     <p:extLst>
       <p:ext uri="{BB962C8B-B14F-4D97-AF65-F5344CB8AC3E}">

</xml_diff>